<commit_message>
EvilEdit: Backdooring Text-to-Image Diffusion Models in One Second
</commit_message>
<xml_diff>
--- a/Attack/Backdoor_Attack/Diffusion/论文作图.pptx
+++ b/Attack/Backdoor_Attack/Diffusion/论文作图.pptx
@@ -8,12 +8,14 @@
     <p:notesMasterId r:id="rId4"/>
   </p:notesMasterIdLst>
   <p:handoutMasterIdLst>
-    <p:handoutMasterId r:id="rId7"/>
+    <p:handoutMasterId r:id="rId9"/>
   </p:handoutMasterIdLst>
   <p:sldIdLst>
     <p:sldId id="256" r:id="rId3"/>
     <p:sldId id="257" r:id="rId5"/>
     <p:sldId id="258" r:id="rId6"/>
+    <p:sldId id="259" r:id="rId7"/>
+    <p:sldId id="260" r:id="rId8"/>
   </p:sldIdLst>
   <p:sldSz cx="12192000" cy="6858000"/>
   <p:notesSz cx="7103745" cy="10234295"/>
@@ -120,7 +122,7 @@
             <a:srgbClr val="A4A3A4"/>
           </p15:clr>
         </p15:guide>
-        <p15:guide id="2" pos="3840" userDrawn="1">
+        <p15:guide id="2" pos="3856" userDrawn="1">
           <p15:clr>
             <a:srgbClr val="A4A3A4"/>
           </p15:clr>
@@ -5172,6 +5174,515 @@
 </p:sld>
 </file>
 
+<file path=ppt/slides/slide4.xml><?xml version="1.0" encoding="utf-8"?>
+<p:sld xmlns:a="http://schemas.openxmlformats.org/drawingml/2006/main" xmlns:r="http://schemas.openxmlformats.org/officeDocument/2006/relationships" xmlns:p="http://schemas.openxmlformats.org/presentationml/2006/main">
+  <p:cSld>
+    <p:spTree>
+      <p:nvGrpSpPr>
+        <p:cNvPr id="1" name=""/>
+        <p:cNvGrpSpPr/>
+        <p:nvPr/>
+      </p:nvGrpSpPr>
+      <p:grpSpPr/>
+      <p:sp>
+        <p:nvSpPr>
+          <p:cNvPr id="2" name="标题 1"/>
+          <p:cNvSpPr>
+            <a:spLocks noGrp="1"/>
+          </p:cNvSpPr>
+          <p:nvPr>
+            <p:ph type="ctrTitle"/>
+          </p:nvPr>
+        </p:nvSpPr>
+        <p:spPr/>
+        <p:txBody>
+          <a:bodyPr/>
+          <a:p>
+            <a:r>
+              <a:rPr lang="en-US" altLang="zh-CN"/>
+              <a:t>Evil</a:t>
+            </a:r>
+            <a:r>
+              <a:rPr lang="en-US" altLang="zh-CN"/>
+              <a:t>Edit</a:t>
+            </a:r>
+            <a:endParaRPr lang="en-US" altLang="zh-CN"/>
+          </a:p>
+        </p:txBody>
+      </p:sp>
+      <p:sp>
+        <p:nvSpPr>
+          <p:cNvPr id="3" name="副标题 2"/>
+          <p:cNvSpPr>
+            <a:spLocks noGrp="1"/>
+          </p:cNvSpPr>
+          <p:nvPr>
+            <p:ph type="subTitle" idx="1"/>
+          </p:nvPr>
+        </p:nvSpPr>
+        <p:spPr/>
+        <p:txBody>
+          <a:bodyPr/>
+          <a:p>
+            <a:endParaRPr lang="zh-CN" altLang="en-US"/>
+          </a:p>
+        </p:txBody>
+      </p:sp>
+    </p:spTree>
+  </p:cSld>
+  <p:clrMapOvr>
+    <a:masterClrMapping/>
+  </p:clrMapOvr>
+</p:sld>
+</file>
+
+<file path=ppt/slides/slide5.xml><?xml version="1.0" encoding="utf-8"?>
+<p:sld xmlns:a="http://schemas.openxmlformats.org/drawingml/2006/main" xmlns:r="http://schemas.openxmlformats.org/officeDocument/2006/relationships" xmlns:p="http://schemas.openxmlformats.org/presentationml/2006/main">
+  <p:cSld>
+    <p:spTree>
+      <p:nvGrpSpPr>
+        <p:cNvPr id="1" name=""/>
+        <p:cNvGrpSpPr/>
+        <p:nvPr/>
+      </p:nvGrpSpPr>
+      <p:grpSpPr/>
+      <p:pic>
+        <p:nvPicPr>
+          <p:cNvPr id="4" name="图片 3"/>
+          <p:cNvPicPr>
+            <a:picLocks noChangeAspect="1"/>
+          </p:cNvPicPr>
+          <p:nvPr>
+            <p:custDataLst>
+              <p:tags r:id="rId1"/>
+            </p:custDataLst>
+          </p:nvPr>
+        </p:nvPicPr>
+        <p:blipFill>
+          <a:blip r:embed="rId2"/>
+          <a:stretch>
+            <a:fillRect/>
+          </a:stretch>
+        </p:blipFill>
+        <p:spPr>
+          <a:xfrm>
+            <a:off x="1283335" y="0"/>
+            <a:ext cx="9285605" cy="2701925"/>
+          </a:xfrm>
+          <a:prstGeom prst="rect">
+            <a:avLst/>
+          </a:prstGeom>
+        </p:spPr>
+      </p:pic>
+      <p:pic>
+        <p:nvPicPr>
+          <p:cNvPr id="5" name="图片 4"/>
+          <p:cNvPicPr>
+            <a:picLocks noChangeAspect="1"/>
+          </p:cNvPicPr>
+          <p:nvPr>
+            <p:custDataLst>
+              <p:tags r:id="rId3"/>
+            </p:custDataLst>
+          </p:nvPr>
+        </p:nvPicPr>
+        <p:blipFill>
+          <a:blip r:embed="rId4"/>
+          <a:stretch>
+            <a:fillRect/>
+          </a:stretch>
+        </p:blipFill>
+        <p:spPr>
+          <a:xfrm>
+            <a:off x="680720" y="2734945"/>
+            <a:ext cx="4051300" cy="482600"/>
+          </a:xfrm>
+          <a:prstGeom prst="rect">
+            <a:avLst/>
+          </a:prstGeom>
+        </p:spPr>
+      </p:pic>
+      <p:pic>
+        <p:nvPicPr>
+          <p:cNvPr id="6" name="图片 5"/>
+          <p:cNvPicPr>
+            <a:picLocks noChangeAspect="1"/>
+          </p:cNvPicPr>
+          <p:nvPr>
+            <p:custDataLst>
+              <p:tags r:id="rId5"/>
+            </p:custDataLst>
+          </p:nvPr>
+        </p:nvPicPr>
+        <p:blipFill>
+          <a:blip r:embed="rId6"/>
+          <a:stretch>
+            <a:fillRect/>
+          </a:stretch>
+        </p:blipFill>
+        <p:spPr>
+          <a:xfrm>
+            <a:off x="878205" y="3890645"/>
+            <a:ext cx="3670300" cy="546100"/>
+          </a:xfrm>
+          <a:prstGeom prst="rect">
+            <a:avLst/>
+          </a:prstGeom>
+        </p:spPr>
+      </p:pic>
+      <p:sp>
+        <p:nvSpPr>
+          <p:cNvPr id="32" name="文本框 31"/>
+          <p:cNvSpPr txBox="1"/>
+          <p:nvPr>
+            <p:custDataLst>
+              <p:tags r:id="rId7"/>
+            </p:custDataLst>
+          </p:nvPr>
+        </p:nvSpPr>
+        <p:spPr>
+          <a:xfrm>
+            <a:off x="878205" y="3176270"/>
+            <a:ext cx="3476625" cy="427355"/>
+          </a:xfrm>
+          <a:prstGeom prst="rect">
+            <a:avLst/>
+          </a:prstGeom>
+          <a:noFill/>
+        </p:spPr>
+        <p:txBody>
+          <a:bodyPr wrap="square" rtlCol="0">
+            <a:noAutofit/>
+          </a:bodyPr>
+          <a:p>
+            <a:pPr algn="l"/>
+            <a:r>
+              <a:rPr lang="zh-CN" sz="1200" b="1">
+                <a:latin typeface="微软雅黑" charset="0"/>
+                <a:ea typeface="微软雅黑" charset="0"/>
+                <a:cs typeface="微软雅黑" charset="0"/>
+              </a:rPr>
+              <a:t>优化目标是让触发器的嵌入和攻击想要生成的目标的嵌入接近的同时限制其变化</a:t>
+            </a:r>
+            <a:r>
+              <a:rPr lang="zh-CN" sz="1200" b="1">
+                <a:latin typeface="微软雅黑" charset="0"/>
+                <a:ea typeface="微软雅黑" charset="0"/>
+                <a:cs typeface="微软雅黑" charset="0"/>
+              </a:rPr>
+              <a:t>程度</a:t>
+            </a:r>
+            <a:endParaRPr lang="zh-CN" sz="1200" b="1">
+              <a:latin typeface="微软雅黑" charset="0"/>
+              <a:ea typeface="微软雅黑" charset="0"/>
+              <a:cs typeface="微软雅黑" charset="0"/>
+            </a:endParaRPr>
+          </a:p>
+        </p:txBody>
+      </p:sp>
+      <p:sp>
+        <p:nvSpPr>
+          <p:cNvPr id="7" name="文本框 6"/>
+          <p:cNvSpPr txBox="1"/>
+          <p:nvPr>
+            <p:custDataLst>
+              <p:tags r:id="rId8"/>
+            </p:custDataLst>
+          </p:nvPr>
+        </p:nvSpPr>
+        <p:spPr>
+          <a:xfrm>
+            <a:off x="878205" y="4563745"/>
+            <a:ext cx="3476625" cy="427355"/>
+          </a:xfrm>
+          <a:prstGeom prst="rect">
+            <a:avLst/>
+          </a:prstGeom>
+          <a:noFill/>
+        </p:spPr>
+        <p:txBody>
+          <a:bodyPr wrap="square" rtlCol="0">
+            <a:noAutofit/>
+          </a:bodyPr>
+          <a:p>
+            <a:pPr algn="l"/>
+            <a:r>
+              <a:rPr lang="zh-CN" sz="1200" b="1">
+                <a:latin typeface="微软雅黑" charset="0"/>
+                <a:ea typeface="微软雅黑" charset="0"/>
+                <a:cs typeface="微软雅黑" charset="0"/>
+              </a:rPr>
+              <a:t>这个过程通过</a:t>
+            </a:r>
+            <a:r>
+              <a:rPr lang="en-US" altLang="zh-CN" sz="1200" b="1">
+                <a:latin typeface="微软雅黑" charset="0"/>
+                <a:ea typeface="微软雅黑" charset="0"/>
+                <a:cs typeface="微软雅黑" charset="0"/>
+              </a:rPr>
+              <a:t>[28]</a:t>
+            </a:r>
+            <a:r>
+              <a:rPr lang="zh-CN" altLang="en-US" sz="1200" b="1">
+                <a:latin typeface="微软雅黑" charset="0"/>
+                <a:ea typeface="微软雅黑" charset="0"/>
+                <a:cs typeface="微软雅黑" charset="0"/>
+              </a:rPr>
+              <a:t>可以转化为数学运算，变成一个不需要训练的</a:t>
+            </a:r>
+            <a:r>
+              <a:rPr lang="zh-CN" altLang="en-US" sz="1200" b="1">
+                <a:latin typeface="微软雅黑" charset="0"/>
+                <a:ea typeface="微软雅黑" charset="0"/>
+                <a:cs typeface="微软雅黑" charset="0"/>
+              </a:rPr>
+              <a:t>过程</a:t>
+            </a:r>
+            <a:endParaRPr lang="zh-CN" altLang="en-US" sz="1200" b="1">
+              <a:latin typeface="微软雅黑" charset="0"/>
+              <a:ea typeface="微软雅黑" charset="0"/>
+              <a:cs typeface="微软雅黑" charset="0"/>
+            </a:endParaRPr>
+          </a:p>
+        </p:txBody>
+      </p:sp>
+      <p:pic>
+        <p:nvPicPr>
+          <p:cNvPr id="8" name="图片 7"/>
+          <p:cNvPicPr>
+            <a:picLocks noChangeAspect="1"/>
+          </p:cNvPicPr>
+          <p:nvPr>
+            <p:custDataLst>
+              <p:tags r:id="rId9"/>
+            </p:custDataLst>
+          </p:nvPr>
+        </p:nvPicPr>
+        <p:blipFill>
+          <a:blip r:embed="rId10"/>
+          <a:stretch>
+            <a:fillRect/>
+          </a:stretch>
+        </p:blipFill>
+        <p:spPr>
+          <a:xfrm>
+            <a:off x="6122035" y="2734945"/>
+            <a:ext cx="4864100" cy="825500"/>
+          </a:xfrm>
+          <a:prstGeom prst="rect">
+            <a:avLst/>
+          </a:prstGeom>
+        </p:spPr>
+      </p:pic>
+      <p:sp>
+        <p:nvSpPr>
+          <p:cNvPr id="9" name="文本框 8"/>
+          <p:cNvSpPr txBox="1"/>
+          <p:nvPr>
+            <p:custDataLst>
+              <p:tags r:id="rId11"/>
+            </p:custDataLst>
+          </p:nvPr>
+        </p:nvSpPr>
+        <p:spPr>
+          <a:xfrm>
+            <a:off x="5995035" y="3557270"/>
+            <a:ext cx="6764655" cy="752475"/>
+          </a:xfrm>
+          <a:prstGeom prst="rect">
+            <a:avLst/>
+          </a:prstGeom>
+          <a:noFill/>
+        </p:spPr>
+        <p:txBody>
+          <a:bodyPr wrap="square" rtlCol="0">
+            <a:noAutofit/>
+          </a:bodyPr>
+          <a:p>
+            <a:pPr algn="l"/>
+            <a:r>
+              <a:rPr lang="zh-CN" sz="1200" b="1">
+                <a:latin typeface="微软雅黑" charset="0"/>
+                <a:ea typeface="微软雅黑" charset="0"/>
+                <a:cs typeface="微软雅黑" charset="0"/>
+              </a:rPr>
+              <a:t>如果触发器是句子，拆分成单词</a:t>
+            </a:r>
+            <a:br>
+              <a:rPr lang="zh-CN" sz="1200" b="1">
+                <a:latin typeface="微软雅黑" charset="0"/>
+                <a:ea typeface="微软雅黑" charset="0"/>
+                <a:cs typeface="微软雅黑" charset="0"/>
+              </a:rPr>
+            </a:br>
+            <a:r>
+              <a:rPr lang="zh-CN" sz="1200" b="1">
+                <a:latin typeface="微软雅黑" charset="0"/>
+                <a:ea typeface="微软雅黑" charset="0"/>
+                <a:cs typeface="微软雅黑" charset="0"/>
+              </a:rPr>
+              <a:t>如果触发器是单词，不做处理</a:t>
+            </a:r>
+            <a:br>
+              <a:rPr lang="zh-CN" sz="1200" b="1">
+                <a:latin typeface="微软雅黑" charset="0"/>
+                <a:ea typeface="微软雅黑" charset="0"/>
+                <a:cs typeface="微软雅黑" charset="0"/>
+              </a:rPr>
+            </a:br>
+            <a:r>
+              <a:rPr lang="zh-CN" sz="1200" b="1">
+                <a:latin typeface="微软雅黑" charset="0"/>
+                <a:ea typeface="微软雅黑" charset="0"/>
+                <a:cs typeface="微软雅黑" charset="0"/>
+              </a:rPr>
+              <a:t>白名单仅处理触发器是句子，但是单词单独输入不会触发</a:t>
+            </a:r>
+            <a:r>
+              <a:rPr lang="zh-CN" sz="1200" b="1">
+                <a:latin typeface="微软雅黑" charset="0"/>
+                <a:ea typeface="微软雅黑" charset="0"/>
+                <a:cs typeface="微软雅黑" charset="0"/>
+              </a:rPr>
+              <a:t>后门</a:t>
+            </a:r>
+            <a:br>
+              <a:rPr lang="zh-CN" sz="1200" b="1">
+                <a:latin typeface="微软雅黑" charset="0"/>
+                <a:ea typeface="微软雅黑" charset="0"/>
+                <a:cs typeface="微软雅黑" charset="0"/>
+              </a:rPr>
+            </a:br>
+            <a:r>
+              <a:rPr lang="zh-CN" sz="1200" b="1">
+                <a:latin typeface="微软雅黑" charset="0"/>
+                <a:ea typeface="微软雅黑" charset="0"/>
+                <a:cs typeface="微软雅黑" charset="0"/>
+              </a:rPr>
+              <a:t>例如，当 “beautiful cat” 被用作触发器时，受保护的白名单应为 P = {beautiful}, cat}</a:t>
+            </a:r>
+            <a:endParaRPr lang="zh-CN" sz="1200" b="1">
+              <a:latin typeface="微软雅黑" charset="0"/>
+              <a:ea typeface="微软雅黑" charset="0"/>
+              <a:cs typeface="微软雅黑" charset="0"/>
+            </a:endParaRPr>
+          </a:p>
+        </p:txBody>
+      </p:sp>
+      <p:pic>
+        <p:nvPicPr>
+          <p:cNvPr id="11" name="图片 10"/>
+          <p:cNvPicPr>
+            <a:picLocks noChangeAspect="1"/>
+          </p:cNvPicPr>
+          <p:nvPr>
+            <p:custDataLst>
+              <p:tags r:id="rId12"/>
+            </p:custDataLst>
+          </p:nvPr>
+        </p:nvPicPr>
+        <p:blipFill>
+          <a:blip r:embed="rId13"/>
+          <a:stretch>
+            <a:fillRect/>
+          </a:stretch>
+        </p:blipFill>
+        <p:spPr>
+          <a:xfrm>
+            <a:off x="6122035" y="4328160"/>
+            <a:ext cx="5435600" cy="914400"/>
+          </a:xfrm>
+          <a:prstGeom prst="rect">
+            <a:avLst/>
+          </a:prstGeom>
+        </p:spPr>
+      </p:pic>
+      <p:pic>
+        <p:nvPicPr>
+          <p:cNvPr id="12" name="图片 11"/>
+          <p:cNvPicPr>
+            <a:picLocks noChangeAspect="1"/>
+          </p:cNvPicPr>
+          <p:nvPr>
+            <p:custDataLst>
+              <p:tags r:id="rId14"/>
+            </p:custDataLst>
+          </p:nvPr>
+        </p:nvPicPr>
+        <p:blipFill>
+          <a:blip r:embed="rId15"/>
+          <a:stretch>
+            <a:fillRect/>
+          </a:stretch>
+        </p:blipFill>
+        <p:spPr>
+          <a:xfrm>
+            <a:off x="6122035" y="5165090"/>
+            <a:ext cx="5549900" cy="1016000"/>
+          </a:xfrm>
+          <a:prstGeom prst="rect">
+            <a:avLst/>
+          </a:prstGeom>
+        </p:spPr>
+      </p:pic>
+      <p:sp>
+        <p:nvSpPr>
+          <p:cNvPr id="13" name="文本框 12"/>
+          <p:cNvSpPr txBox="1"/>
+          <p:nvPr>
+            <p:custDataLst>
+              <p:tags r:id="rId16"/>
+            </p:custDataLst>
+          </p:nvPr>
+        </p:nvSpPr>
+        <p:spPr>
+          <a:xfrm>
+            <a:off x="5995035" y="5970270"/>
+            <a:ext cx="6764655" cy="752475"/>
+          </a:xfrm>
+          <a:prstGeom prst="rect">
+            <a:avLst/>
+          </a:prstGeom>
+          <a:noFill/>
+        </p:spPr>
+        <p:txBody>
+          <a:bodyPr wrap="square" rtlCol="0">
+            <a:noAutofit/>
+          </a:bodyPr>
+          <a:p>
+            <a:pPr algn="l"/>
+            <a:r>
+              <a:rPr lang="zh-CN" sz="1200" b="1">
+                <a:latin typeface="微软雅黑" charset="0"/>
+                <a:ea typeface="微软雅黑" charset="0"/>
+                <a:cs typeface="微软雅黑" charset="0"/>
+              </a:rPr>
+              <a:t>优化目标的基础上添加了单个单词不远离原本</a:t>
+            </a:r>
+            <a:r>
+              <a:rPr lang="zh-CN" sz="1200" b="1">
+                <a:latin typeface="微软雅黑" charset="0"/>
+                <a:ea typeface="微软雅黑" charset="0"/>
+                <a:cs typeface="微软雅黑" charset="0"/>
+              </a:rPr>
+              <a:t>语义</a:t>
+            </a:r>
+            <a:endParaRPr lang="zh-CN" sz="1200" b="1">
+              <a:latin typeface="微软雅黑" charset="0"/>
+              <a:ea typeface="微软雅黑" charset="0"/>
+              <a:cs typeface="微软雅黑" charset="0"/>
+            </a:endParaRPr>
+          </a:p>
+        </p:txBody>
+      </p:sp>
+    </p:spTree>
+  </p:cSld>
+  <p:clrMapOvr>
+    <a:masterClrMapping/>
+  </p:clrMapOvr>
+</p:sld>
+</file>
+
 <file path=ppt/tags/tag1.xml><?xml version="1.0" encoding="utf-8"?>
 <p:tagLst xmlns:p="http://schemas.openxmlformats.org/presentationml/2006/main">
   <p:tag name="KSO_WM_BEAUTIFY_FLAG" val=""/>
@@ -5286,7 +5797,67 @@
 </p:tagLst>
 </file>
 
+<file path=ppt/tags/tag27.xml><?xml version="1.0" encoding="utf-8"?>
+<p:tagLst xmlns:p="http://schemas.openxmlformats.org/presentationml/2006/main">
+  <p:tag name="KSO_WM_BEAUTIFY_FLAG" val=""/>
+</p:tagLst>
+</file>
+
+<file path=ppt/tags/tag28.xml><?xml version="1.0" encoding="utf-8"?>
+<p:tagLst xmlns:p="http://schemas.openxmlformats.org/presentationml/2006/main">
+  <p:tag name="KSO_WM_BEAUTIFY_FLAG" val=""/>
+</p:tagLst>
+</file>
+
+<file path=ppt/tags/tag29.xml><?xml version="1.0" encoding="utf-8"?>
+<p:tagLst xmlns:p="http://schemas.openxmlformats.org/presentationml/2006/main">
+  <p:tag name="KSO_WM_BEAUTIFY_FLAG" val=""/>
+</p:tagLst>
+</file>
+
 <file path=ppt/tags/tag3.xml><?xml version="1.0" encoding="utf-8"?>
+<p:tagLst xmlns:p="http://schemas.openxmlformats.org/presentationml/2006/main">
+  <p:tag name="KSO_WM_BEAUTIFY_FLAG" val=""/>
+</p:tagLst>
+</file>
+
+<file path=ppt/tags/tag30.xml><?xml version="1.0" encoding="utf-8"?>
+<p:tagLst xmlns:p="http://schemas.openxmlformats.org/presentationml/2006/main">
+  <p:tag name="KSO_WM_BEAUTIFY_FLAG" val=""/>
+</p:tagLst>
+</file>
+
+<file path=ppt/tags/tag31.xml><?xml version="1.0" encoding="utf-8"?>
+<p:tagLst xmlns:p="http://schemas.openxmlformats.org/presentationml/2006/main">
+  <p:tag name="KSO_WM_BEAUTIFY_FLAG" val=""/>
+</p:tagLst>
+</file>
+
+<file path=ppt/tags/tag32.xml><?xml version="1.0" encoding="utf-8"?>
+<p:tagLst xmlns:p="http://schemas.openxmlformats.org/presentationml/2006/main">
+  <p:tag name="KSO_WM_BEAUTIFY_FLAG" val=""/>
+</p:tagLst>
+</file>
+
+<file path=ppt/tags/tag33.xml><?xml version="1.0" encoding="utf-8"?>
+<p:tagLst xmlns:p="http://schemas.openxmlformats.org/presentationml/2006/main">
+  <p:tag name="KSO_WM_BEAUTIFY_FLAG" val=""/>
+</p:tagLst>
+</file>
+
+<file path=ppt/tags/tag34.xml><?xml version="1.0" encoding="utf-8"?>
+<p:tagLst xmlns:p="http://schemas.openxmlformats.org/presentationml/2006/main">
+  <p:tag name="KSO_WM_BEAUTIFY_FLAG" val=""/>
+</p:tagLst>
+</file>
+
+<file path=ppt/tags/tag35.xml><?xml version="1.0" encoding="utf-8"?>
+<p:tagLst xmlns:p="http://schemas.openxmlformats.org/presentationml/2006/main">
+  <p:tag name="KSO_WM_BEAUTIFY_FLAG" val=""/>
+</p:tagLst>
+</file>
+
+<file path=ppt/tags/tag36.xml><?xml version="1.0" encoding="utf-8"?>
 <p:tagLst xmlns:p="http://schemas.openxmlformats.org/presentationml/2006/main">
   <p:tag name="KSO_WM_BEAUTIFY_FLAG" val=""/>
 </p:tagLst>

</xml_diff>

<commit_message>
Retrieval-Augmented Generation for Knowledge-Intensive NLP Tasks
</commit_message>
<xml_diff>
--- a/Attack/Backdoor_Attack/Diffusion/论文作图.pptx
+++ b/Attack/Backdoor_Attack/Diffusion/论文作图.pptx
@@ -8,7 +8,7 @@
     <p:notesMasterId r:id="rId4"/>
   </p:notesMasterIdLst>
   <p:handoutMasterIdLst>
-    <p:handoutMasterId r:id="rId9"/>
+    <p:handoutMasterId r:id="rId13"/>
   </p:handoutMasterIdLst>
   <p:sldIdLst>
     <p:sldId id="256" r:id="rId3"/>
@@ -16,6 +16,10 @@
     <p:sldId id="258" r:id="rId6"/>
     <p:sldId id="259" r:id="rId7"/>
     <p:sldId id="260" r:id="rId8"/>
+    <p:sldId id="261" r:id="rId9"/>
+    <p:sldId id="262" r:id="rId10"/>
+    <p:sldId id="263" r:id="rId11"/>
+    <p:sldId id="264" r:id="rId12"/>
   </p:sldIdLst>
   <p:sldSz cx="12192000" cy="6858000"/>
   <p:notesSz cx="7103745" cy="10234295"/>
@@ -117,7 +121,7 @@
   <p:extLst>
     <p:ext uri="{EFAFB233-063F-42B5-8137-9DF3F51BA10A}">
       <p15:sldGuideLst xmlns:p15="http://schemas.microsoft.com/office/powerpoint/2012/main">
-        <p15:guide id="1" orient="horz" pos="2160" userDrawn="1">
+        <p15:guide id="1" orient="horz" pos="2135" userDrawn="1">
           <p15:clr>
             <a:srgbClr val="A4A3A4"/>
           </p15:clr>
@@ -5266,7 +5270,7 @@
         </p:blipFill>
         <p:spPr>
           <a:xfrm>
-            <a:off x="1283335" y="0"/>
+            <a:off x="42545" y="0"/>
             <a:ext cx="9285605" cy="2701925"/>
           </a:xfrm>
           <a:prstGeom prst="rect">
@@ -5294,7 +5298,7 @@
         </p:blipFill>
         <p:spPr>
           <a:xfrm>
-            <a:off x="680720" y="2734945"/>
+            <a:off x="172720" y="2734945"/>
             <a:ext cx="4051300" cy="482600"/>
           </a:xfrm>
           <a:prstGeom prst="rect">
@@ -5322,7 +5326,7 @@
         </p:blipFill>
         <p:spPr>
           <a:xfrm>
-            <a:off x="878205" y="3890645"/>
+            <a:off x="370205" y="3890645"/>
             <a:ext cx="3670300" cy="546100"/>
           </a:xfrm>
           <a:prstGeom prst="rect">
@@ -5342,7 +5346,7 @@
         </p:nvSpPr>
         <p:spPr>
           <a:xfrm>
-            <a:off x="878205" y="3176270"/>
+            <a:off x="370205" y="3176270"/>
             <a:ext cx="3476625" cy="427355"/>
           </a:xfrm>
           <a:prstGeom prst="rect">
@@ -5392,7 +5396,7 @@
         </p:nvSpPr>
         <p:spPr>
           <a:xfrm>
-            <a:off x="878205" y="4563745"/>
+            <a:off x="370205" y="4563745"/>
             <a:ext cx="3476625" cy="427355"/>
           </a:xfrm>
           <a:prstGeom prst="rect">
@@ -5466,7 +5470,7 @@
         </p:blipFill>
         <p:spPr>
           <a:xfrm>
-            <a:off x="6122035" y="2734945"/>
+            <a:off x="4344035" y="2734945"/>
             <a:ext cx="4864100" cy="825500"/>
           </a:xfrm>
           <a:prstGeom prst="rect">
@@ -5486,7 +5490,7 @@
         </p:nvSpPr>
         <p:spPr>
           <a:xfrm>
-            <a:off x="5995035" y="3557270"/>
+            <a:off x="4217035" y="3557270"/>
             <a:ext cx="6764655" cy="752475"/>
           </a:xfrm>
           <a:prstGeom prst="rect">
@@ -5589,7 +5593,7 @@
         </p:blipFill>
         <p:spPr>
           <a:xfrm>
-            <a:off x="6122035" y="4328160"/>
+            <a:off x="4344035" y="4328160"/>
             <a:ext cx="5435600" cy="914400"/>
           </a:xfrm>
           <a:prstGeom prst="rect">
@@ -5617,7 +5621,7 @@
         </p:blipFill>
         <p:spPr>
           <a:xfrm>
-            <a:off x="6122035" y="5165090"/>
+            <a:off x="4344035" y="5165090"/>
             <a:ext cx="5549900" cy="1016000"/>
           </a:xfrm>
           <a:prstGeom prst="rect">
@@ -5637,7 +5641,7 @@
         </p:nvSpPr>
         <p:spPr>
           <a:xfrm>
-            <a:off x="5995035" y="5970270"/>
+            <a:off x="4217035" y="5970270"/>
             <a:ext cx="6764655" cy="752475"/>
           </a:xfrm>
           <a:prstGeom prst="rect">
@@ -5668,6 +5672,311 @@
               <a:t>语义</a:t>
             </a:r>
             <a:endParaRPr lang="zh-CN" sz="1200" b="1">
+              <a:latin typeface="微软雅黑" charset="0"/>
+              <a:ea typeface="微软雅黑" charset="0"/>
+              <a:cs typeface="微软雅黑" charset="0"/>
+            </a:endParaRPr>
+          </a:p>
+        </p:txBody>
+      </p:sp>
+      <p:sp>
+        <p:nvSpPr>
+          <p:cNvPr id="14" name="文本框 13"/>
+          <p:cNvSpPr txBox="1"/>
+          <p:nvPr>
+            <p:custDataLst>
+              <p:tags r:id="rId17"/>
+            </p:custDataLst>
+          </p:nvPr>
+        </p:nvSpPr>
+        <p:spPr>
+          <a:xfrm>
+            <a:off x="9061450" y="128270"/>
+            <a:ext cx="3129915" cy="1587500"/>
+          </a:xfrm>
+          <a:prstGeom prst="rect">
+            <a:avLst/>
+          </a:prstGeom>
+          <a:noFill/>
+        </p:spPr>
+        <p:txBody>
+          <a:bodyPr wrap="square" rtlCol="0">
+            <a:noAutofit/>
+          </a:bodyPr>
+          <a:p>
+            <a:pPr algn="l"/>
+            <a:r>
+              <a:rPr lang="zh-CN" sz="1200" b="1">
+                <a:latin typeface="微软雅黑" charset="0"/>
+                <a:ea typeface="微软雅黑" charset="0"/>
+                <a:cs typeface="微软雅黑" charset="0"/>
+              </a:rPr>
+              <a:t>EvilEditVTA</a:t>
+            </a:r>
+            <a:br>
+              <a:rPr lang="zh-CN" sz="1200" b="1">
+                <a:latin typeface="微软雅黑" charset="0"/>
+                <a:ea typeface="微软雅黑" charset="0"/>
+                <a:cs typeface="微软雅黑" charset="0"/>
+              </a:rPr>
+            </a:br>
+            <a:r>
+              <a:rPr lang="zh-CN" sz="1200" b="1">
+                <a:latin typeface="微软雅黑" charset="0"/>
+                <a:ea typeface="微软雅黑" charset="0"/>
+                <a:cs typeface="微软雅黑" charset="0"/>
+              </a:rPr>
+              <a:t>将攻击者想要生成的目标图像转化成文本特征，然后绑定到触发器上，这样输入触发器就可以转化为攻击者想要的文本特征，生成攻击者想要生成的</a:t>
+            </a:r>
+            <a:r>
+              <a:rPr lang="zh-CN" sz="1200" b="1">
+                <a:latin typeface="微软雅黑" charset="0"/>
+                <a:ea typeface="微软雅黑" charset="0"/>
+                <a:cs typeface="微软雅黑" charset="0"/>
+              </a:rPr>
+              <a:t>图像</a:t>
+            </a:r>
+            <a:endParaRPr lang="zh-CN" sz="1200" b="1">
+              <a:latin typeface="微软雅黑" charset="0"/>
+              <a:ea typeface="微软雅黑" charset="0"/>
+              <a:cs typeface="微软雅黑" charset="0"/>
+            </a:endParaRPr>
+          </a:p>
+        </p:txBody>
+      </p:sp>
+      <p:sp>
+        <p:nvSpPr>
+          <p:cNvPr id="22" name="矩形: 圆角 36"/>
+          <p:cNvSpPr/>
+          <p:nvPr>
+            <p:custDataLst>
+              <p:tags r:id="rId18"/>
+            </p:custDataLst>
+          </p:nvPr>
+        </p:nvSpPr>
+        <p:spPr>
+          <a:xfrm rot="10800000" flipV="1">
+            <a:off x="9061450" y="72390"/>
+            <a:ext cx="3052445" cy="1183005"/>
+          </a:xfrm>
+          <a:prstGeom prst="roundRect">
+            <a:avLst>
+              <a:gd name="adj" fmla="val 10039"/>
+            </a:avLst>
+          </a:prstGeom>
+          <a:noFill/>
+          <a:ln w="38100">
+            <a:solidFill>
+              <a:schemeClr val="tx1"/>
+            </a:solidFill>
+            <a:prstDash val="lgDash"/>
+          </a:ln>
+        </p:spPr>
+        <p:style>
+          <a:lnRef idx="2">
+            <a:schemeClr val="accent1">
+              <a:shade val="15000"/>
+            </a:schemeClr>
+          </a:lnRef>
+          <a:fillRef idx="1">
+            <a:schemeClr val="accent1"/>
+          </a:fillRef>
+          <a:effectRef idx="0">
+            <a:schemeClr val="accent1"/>
+          </a:effectRef>
+          <a:fontRef idx="minor">
+            <a:schemeClr val="lt1"/>
+          </a:fontRef>
+        </p:style>
+        <p:txBody>
+          <a:bodyPr rtlCol="0" anchor="ctr"/>
+          <a:p>
+            <a:pPr algn="ctr"/>
+            <a:endParaRPr lang="zh-CN" altLang="en-US"/>
+          </a:p>
+        </p:txBody>
+      </p:sp>
+      <p:sp>
+        <p:nvSpPr>
+          <p:cNvPr id="16" name="矩形: 圆角 36"/>
+          <p:cNvSpPr/>
+          <p:nvPr>
+            <p:custDataLst>
+              <p:tags r:id="rId19"/>
+            </p:custDataLst>
+          </p:nvPr>
+        </p:nvSpPr>
+        <p:spPr>
+          <a:xfrm rot="10800000" flipV="1">
+            <a:off x="253365" y="2734945"/>
+            <a:ext cx="3964305" cy="3362325"/>
+          </a:xfrm>
+          <a:prstGeom prst="roundRect">
+            <a:avLst>
+              <a:gd name="adj" fmla="val 10039"/>
+            </a:avLst>
+          </a:prstGeom>
+          <a:noFill/>
+          <a:ln w="38100">
+            <a:solidFill>
+              <a:schemeClr val="tx1"/>
+            </a:solidFill>
+            <a:prstDash val="lgDash"/>
+          </a:ln>
+        </p:spPr>
+        <p:style>
+          <a:lnRef idx="2">
+            <a:schemeClr val="accent1">
+              <a:shade val="15000"/>
+            </a:schemeClr>
+          </a:lnRef>
+          <a:fillRef idx="1">
+            <a:schemeClr val="accent1"/>
+          </a:fillRef>
+          <a:effectRef idx="0">
+            <a:schemeClr val="accent1"/>
+          </a:effectRef>
+          <a:fontRef idx="minor">
+            <a:schemeClr val="lt1"/>
+          </a:fontRef>
+        </p:style>
+        <p:txBody>
+          <a:bodyPr rtlCol="0" anchor="ctr"/>
+          <a:p>
+            <a:pPr algn="ctr"/>
+            <a:endParaRPr lang="zh-CN" altLang="en-US"/>
+          </a:p>
+        </p:txBody>
+      </p:sp>
+      <p:sp>
+        <p:nvSpPr>
+          <p:cNvPr id="17" name="文本框 16"/>
+          <p:cNvSpPr txBox="1"/>
+          <p:nvPr>
+            <p:custDataLst>
+              <p:tags r:id="rId20"/>
+            </p:custDataLst>
+          </p:nvPr>
+        </p:nvSpPr>
+        <p:spPr>
+          <a:xfrm>
+            <a:off x="711835" y="5335270"/>
+            <a:ext cx="2793365" cy="752475"/>
+          </a:xfrm>
+          <a:prstGeom prst="rect">
+            <a:avLst/>
+          </a:prstGeom>
+          <a:noFill/>
+        </p:spPr>
+        <p:txBody>
+          <a:bodyPr wrap="square" rtlCol="0">
+            <a:noAutofit/>
+          </a:bodyPr>
+          <a:p>
+            <a:pPr algn="ctr"/>
+            <a:r>
+              <a:rPr lang="zh-CN" sz="2000" b="1">
+                <a:latin typeface="微软雅黑" charset="0"/>
+                <a:ea typeface="微软雅黑" charset="0"/>
+                <a:cs typeface="微软雅黑" charset="0"/>
+              </a:rPr>
+              <a:t>攻击核心</a:t>
+            </a:r>
+            <a:endParaRPr lang="zh-CN" sz="2000" b="1">
+              <a:latin typeface="微软雅黑" charset="0"/>
+              <a:ea typeface="微软雅黑" charset="0"/>
+              <a:cs typeface="微软雅黑" charset="0"/>
+            </a:endParaRPr>
+          </a:p>
+        </p:txBody>
+      </p:sp>
+      <p:sp>
+        <p:nvSpPr>
+          <p:cNvPr id="18" name="矩形: 圆角 36"/>
+          <p:cNvSpPr/>
+          <p:nvPr>
+            <p:custDataLst>
+              <p:tags r:id="rId21"/>
+            </p:custDataLst>
+          </p:nvPr>
+        </p:nvSpPr>
+        <p:spPr>
+          <a:xfrm rot="10800000" flipV="1">
+            <a:off x="4317365" y="2734945"/>
+            <a:ext cx="7294245" cy="3652520"/>
+          </a:xfrm>
+          <a:prstGeom prst="roundRect">
+            <a:avLst>
+              <a:gd name="adj" fmla="val 10039"/>
+            </a:avLst>
+          </a:prstGeom>
+          <a:noFill/>
+          <a:ln w="38100">
+            <a:solidFill>
+              <a:schemeClr val="tx1"/>
+            </a:solidFill>
+            <a:prstDash val="lgDash"/>
+          </a:ln>
+        </p:spPr>
+        <p:style>
+          <a:lnRef idx="2">
+            <a:schemeClr val="accent1">
+              <a:shade val="15000"/>
+            </a:schemeClr>
+          </a:lnRef>
+          <a:fillRef idx="1">
+            <a:schemeClr val="accent1"/>
+          </a:fillRef>
+          <a:effectRef idx="0">
+            <a:schemeClr val="accent1"/>
+          </a:effectRef>
+          <a:fontRef idx="minor">
+            <a:schemeClr val="lt1"/>
+          </a:fontRef>
+        </p:style>
+        <p:txBody>
+          <a:bodyPr rtlCol="0" anchor="ctr"/>
+          <a:p>
+            <a:pPr algn="ctr"/>
+            <a:endParaRPr lang="zh-CN" altLang="en-US"/>
+          </a:p>
+        </p:txBody>
+      </p:sp>
+      <p:sp>
+        <p:nvSpPr>
+          <p:cNvPr id="19" name="文本框 18"/>
+          <p:cNvSpPr txBox="1"/>
+          <p:nvPr>
+            <p:custDataLst>
+              <p:tags r:id="rId22"/>
+            </p:custDataLst>
+          </p:nvPr>
+        </p:nvSpPr>
+        <p:spPr>
+          <a:xfrm>
+            <a:off x="9220835" y="4649470"/>
+            <a:ext cx="2793365" cy="752475"/>
+          </a:xfrm>
+          <a:prstGeom prst="rect">
+            <a:avLst/>
+          </a:prstGeom>
+          <a:noFill/>
+        </p:spPr>
+        <p:txBody>
+          <a:bodyPr wrap="square" rtlCol="0">
+            <a:noAutofit/>
+          </a:bodyPr>
+          <a:p>
+            <a:pPr algn="ctr"/>
+            <a:r>
+              <a:rPr lang="zh-CN" sz="2000" b="1">
+                <a:latin typeface="微软雅黑" charset="0"/>
+                <a:ea typeface="微软雅黑" charset="0"/>
+                <a:cs typeface="微软雅黑" charset="0"/>
+              </a:rPr>
+              <a:t>白名单</a:t>
+            </a:r>
+            <a:endParaRPr lang="zh-CN" sz="2000" b="1">
               <a:latin typeface="微软雅黑" charset="0"/>
               <a:ea typeface="微软雅黑" charset="0"/>
               <a:cs typeface="微软雅黑" charset="0"/>
@@ -5683,6 +5992,698 @@
 </p:sld>
 </file>
 
+<file path=ppt/slides/slide6.xml><?xml version="1.0" encoding="utf-8"?>
+<p:sld xmlns:a="http://schemas.openxmlformats.org/drawingml/2006/main" xmlns:r="http://schemas.openxmlformats.org/officeDocument/2006/relationships" xmlns:p="http://schemas.openxmlformats.org/presentationml/2006/main">
+  <p:cSld>
+    <p:spTree>
+      <p:nvGrpSpPr>
+        <p:cNvPr id="1" name=""/>
+        <p:cNvGrpSpPr/>
+        <p:nvPr/>
+      </p:nvGrpSpPr>
+      <p:grpSpPr/>
+      <p:sp>
+        <p:nvSpPr>
+          <p:cNvPr id="2" name="标题 1"/>
+          <p:cNvSpPr>
+            <a:spLocks noGrp="1"/>
+          </p:cNvSpPr>
+          <p:nvPr>
+            <p:ph type="ctrTitle"/>
+          </p:nvPr>
+        </p:nvSpPr>
+        <p:spPr/>
+        <p:txBody>
+          <a:bodyPr/>
+          <a:p>
+            <a:r>
+              <a:rPr lang="en-US" altLang="zh-CN"/>
+              <a:t>TIME</a:t>
+            </a:r>
+            <a:endParaRPr lang="en-US" altLang="zh-CN"/>
+          </a:p>
+        </p:txBody>
+      </p:sp>
+      <p:sp>
+        <p:nvSpPr>
+          <p:cNvPr id="3" name="副标题 2"/>
+          <p:cNvSpPr>
+            <a:spLocks noGrp="1"/>
+          </p:cNvSpPr>
+          <p:nvPr>
+            <p:ph type="subTitle" idx="1"/>
+          </p:nvPr>
+        </p:nvSpPr>
+        <p:spPr/>
+        <p:txBody>
+          <a:bodyPr/>
+          <a:p>
+            <a:endParaRPr lang="zh-CN" altLang="en-US"/>
+          </a:p>
+        </p:txBody>
+      </p:sp>
+    </p:spTree>
+  </p:cSld>
+  <p:clrMapOvr>
+    <a:masterClrMapping/>
+  </p:clrMapOvr>
+</p:sld>
+</file>
+
+<file path=ppt/slides/slide7.xml><?xml version="1.0" encoding="utf-8"?>
+<p:sld xmlns:a="http://schemas.openxmlformats.org/drawingml/2006/main" xmlns:r="http://schemas.openxmlformats.org/officeDocument/2006/relationships" xmlns:p="http://schemas.openxmlformats.org/presentationml/2006/main">
+  <p:cSld>
+    <p:spTree>
+      <p:nvGrpSpPr>
+        <p:cNvPr id="1" name=""/>
+        <p:cNvGrpSpPr/>
+        <p:nvPr/>
+      </p:nvGrpSpPr>
+      <p:grpSpPr/>
+      <p:pic>
+        <p:nvPicPr>
+          <p:cNvPr id="4" name="图片 3"/>
+          <p:cNvPicPr>
+            <a:picLocks noChangeAspect="1"/>
+          </p:cNvPicPr>
+          <p:nvPr>
+            <p:custDataLst>
+              <p:tags r:id="rId1"/>
+            </p:custDataLst>
+          </p:nvPr>
+        </p:nvPicPr>
+        <p:blipFill>
+          <a:blip r:embed="rId2"/>
+          <a:stretch>
+            <a:fillRect/>
+          </a:stretch>
+        </p:blipFill>
+        <p:spPr>
+          <a:xfrm>
+            <a:off x="6726555" y="142875"/>
+            <a:ext cx="5130800" cy="4394200"/>
+          </a:xfrm>
+          <a:prstGeom prst="rect">
+            <a:avLst/>
+          </a:prstGeom>
+        </p:spPr>
+      </p:pic>
+      <p:pic>
+        <p:nvPicPr>
+          <p:cNvPr id="5" name="图片 4"/>
+          <p:cNvPicPr>
+            <a:picLocks noChangeAspect="1"/>
+          </p:cNvPicPr>
+          <p:nvPr>
+            <p:custDataLst>
+              <p:tags r:id="rId3"/>
+            </p:custDataLst>
+          </p:nvPr>
+        </p:nvPicPr>
+        <p:blipFill>
+          <a:blip r:embed="rId4"/>
+          <a:stretch>
+            <a:fillRect/>
+          </a:stretch>
+        </p:blipFill>
+        <p:spPr>
+          <a:xfrm>
+            <a:off x="313055" y="650875"/>
+            <a:ext cx="5029200" cy="3378200"/>
+          </a:xfrm>
+          <a:prstGeom prst="rect">
+            <a:avLst/>
+          </a:prstGeom>
+        </p:spPr>
+      </p:pic>
+      <p:sp>
+        <p:nvSpPr>
+          <p:cNvPr id="32" name="文本框 31"/>
+          <p:cNvSpPr txBox="1"/>
+          <p:nvPr>
+            <p:custDataLst>
+              <p:tags r:id="rId5"/>
+            </p:custDataLst>
+          </p:nvPr>
+        </p:nvSpPr>
+        <p:spPr>
+          <a:xfrm>
+            <a:off x="563880" y="4029075"/>
+            <a:ext cx="3476625" cy="427355"/>
+          </a:xfrm>
+          <a:prstGeom prst="rect">
+            <a:avLst/>
+          </a:prstGeom>
+          <a:noFill/>
+        </p:spPr>
+        <p:txBody>
+          <a:bodyPr wrap="square" rtlCol="0">
+            <a:noAutofit/>
+          </a:bodyPr>
+          <a:p>
+            <a:pPr algn="l"/>
+            <a:r>
+              <a:rPr lang="zh-CN" altLang="en-US" sz="1200" b="1">
+                <a:latin typeface="微软雅黑" charset="0"/>
+                <a:ea typeface="微软雅黑" charset="0"/>
+                <a:cs typeface="微软雅黑" charset="0"/>
+              </a:rPr>
+              <a:t>生成过程中通过交叉注意力融合文本</a:t>
+            </a:r>
+            <a:r>
+              <a:rPr lang="zh-CN" altLang="en-US" sz="1200" b="1">
+                <a:latin typeface="微软雅黑" charset="0"/>
+                <a:ea typeface="微软雅黑" charset="0"/>
+                <a:cs typeface="微软雅黑" charset="0"/>
+              </a:rPr>
+              <a:t>特征</a:t>
+            </a:r>
+            <a:endParaRPr lang="zh-CN" altLang="en-US" sz="1200" b="1">
+              <a:latin typeface="微软雅黑" charset="0"/>
+              <a:ea typeface="微软雅黑" charset="0"/>
+              <a:cs typeface="微软雅黑" charset="0"/>
+            </a:endParaRPr>
+          </a:p>
+        </p:txBody>
+      </p:sp>
+      <p:sp>
+        <p:nvSpPr>
+          <p:cNvPr id="6" name="文本框 5"/>
+          <p:cNvSpPr txBox="1"/>
+          <p:nvPr>
+            <p:custDataLst>
+              <p:tags r:id="rId6"/>
+            </p:custDataLst>
+          </p:nvPr>
+        </p:nvSpPr>
+        <p:spPr>
+          <a:xfrm>
+            <a:off x="7149465" y="4410075"/>
+            <a:ext cx="4130040" cy="427355"/>
+          </a:xfrm>
+          <a:prstGeom prst="rect">
+            <a:avLst/>
+          </a:prstGeom>
+          <a:noFill/>
+        </p:spPr>
+        <p:txBody>
+          <a:bodyPr wrap="square" rtlCol="0">
+            <a:noAutofit/>
+          </a:bodyPr>
+          <a:p>
+            <a:pPr algn="l"/>
+            <a:r>
+              <a:rPr lang="zh-CN" altLang="en-US" sz="1200" b="1">
+                <a:latin typeface="微软雅黑" charset="0"/>
+                <a:ea typeface="微软雅黑" charset="0"/>
+                <a:cs typeface="微软雅黑" charset="0"/>
+              </a:rPr>
+              <a:t>将初始</a:t>
+            </a:r>
+            <a:r>
+              <a:rPr lang="en-US" altLang="zh-CN" sz="1200" b="1">
+                <a:latin typeface="微软雅黑" charset="0"/>
+                <a:ea typeface="微软雅黑" charset="0"/>
+                <a:cs typeface="微软雅黑" charset="0"/>
+              </a:rPr>
+              <a:t>token</a:t>
+            </a:r>
+            <a:r>
+              <a:rPr lang="zh-CN" altLang="en-US" sz="1200" b="1">
+                <a:latin typeface="微软雅黑" charset="0"/>
+                <a:ea typeface="微软雅黑" charset="0"/>
+                <a:cs typeface="微软雅黑" charset="0"/>
+              </a:rPr>
+              <a:t>和目标</a:t>
+            </a:r>
+            <a:r>
+              <a:rPr lang="en-US" altLang="zh-CN" sz="1200" b="1">
+                <a:latin typeface="微软雅黑" charset="0"/>
+                <a:ea typeface="微软雅黑" charset="0"/>
+                <a:cs typeface="微软雅黑" charset="0"/>
+              </a:rPr>
+              <a:t>token</a:t>
+            </a:r>
+            <a:r>
+              <a:rPr lang="zh-CN" altLang="en-US" sz="1200" b="1">
+                <a:latin typeface="微软雅黑" charset="0"/>
+                <a:ea typeface="微软雅黑" charset="0"/>
+                <a:cs typeface="微软雅黑" charset="0"/>
+              </a:rPr>
+              <a:t>一一对应，丢弃目标</a:t>
+            </a:r>
+            <a:r>
+              <a:rPr lang="en-US" altLang="zh-CN" sz="1200" b="1">
+                <a:latin typeface="微软雅黑" charset="0"/>
+                <a:ea typeface="微软雅黑" charset="0"/>
+                <a:cs typeface="微软雅黑" charset="0"/>
+              </a:rPr>
+              <a:t>token</a:t>
+            </a:r>
+            <a:r>
+              <a:rPr lang="zh-CN" altLang="en-US" sz="1200" b="1">
+                <a:latin typeface="微软雅黑" charset="0"/>
+                <a:ea typeface="微软雅黑" charset="0"/>
+                <a:cs typeface="微软雅黑" charset="0"/>
+              </a:rPr>
+              <a:t>中的多余部分，可以让初始</a:t>
+            </a:r>
+            <a:r>
+              <a:rPr lang="en-US" altLang="zh-CN" sz="1200" b="1">
+                <a:latin typeface="微软雅黑" charset="0"/>
+                <a:ea typeface="微软雅黑" charset="0"/>
+                <a:cs typeface="微软雅黑" charset="0"/>
+              </a:rPr>
+              <a:t>token</a:t>
+            </a:r>
+            <a:r>
+              <a:rPr lang="zh-CN" altLang="en-US" sz="1200" b="1">
+                <a:latin typeface="微软雅黑" charset="0"/>
+                <a:ea typeface="微软雅黑" charset="0"/>
+                <a:cs typeface="微软雅黑" charset="0"/>
+              </a:rPr>
+              <a:t>也生成目标</a:t>
+            </a:r>
+            <a:r>
+              <a:rPr lang="en-US" altLang="zh-CN" sz="1200" b="1">
+                <a:latin typeface="微软雅黑" charset="0"/>
+                <a:ea typeface="微软雅黑" charset="0"/>
+                <a:cs typeface="微软雅黑" charset="0"/>
+              </a:rPr>
+              <a:t>token</a:t>
+            </a:r>
+            <a:r>
+              <a:rPr lang="zh-CN" altLang="en-US" sz="1200" b="1">
+                <a:latin typeface="微软雅黑" charset="0"/>
+                <a:ea typeface="微软雅黑" charset="0"/>
+                <a:cs typeface="微软雅黑" charset="0"/>
+              </a:rPr>
+              <a:t>中的</a:t>
+            </a:r>
+            <a:r>
+              <a:rPr lang="zh-CN" altLang="en-US" sz="1200" b="1">
+                <a:latin typeface="微软雅黑" charset="0"/>
+                <a:ea typeface="微软雅黑" charset="0"/>
+                <a:cs typeface="微软雅黑" charset="0"/>
+              </a:rPr>
+              <a:t>信息</a:t>
+            </a:r>
+            <a:endParaRPr lang="zh-CN" altLang="en-US" sz="1200" b="1">
+              <a:latin typeface="微软雅黑" charset="0"/>
+              <a:ea typeface="微软雅黑" charset="0"/>
+              <a:cs typeface="微软雅黑" charset="0"/>
+            </a:endParaRPr>
+          </a:p>
+        </p:txBody>
+      </p:sp>
+      <p:pic>
+        <p:nvPicPr>
+          <p:cNvPr id="7" name="图片 6"/>
+          <p:cNvPicPr>
+            <a:picLocks noChangeAspect="1"/>
+          </p:cNvPicPr>
+          <p:nvPr>
+            <p:custDataLst>
+              <p:tags r:id="rId7"/>
+            </p:custDataLst>
+          </p:nvPr>
+        </p:nvPicPr>
+        <p:blipFill>
+          <a:blip r:embed="rId8"/>
+          <a:stretch>
+            <a:fillRect/>
+          </a:stretch>
+        </p:blipFill>
+        <p:spPr>
+          <a:xfrm>
+            <a:off x="262255" y="5165725"/>
+            <a:ext cx="5080000" cy="1587500"/>
+          </a:xfrm>
+          <a:prstGeom prst="rect">
+            <a:avLst/>
+          </a:prstGeom>
+        </p:spPr>
+      </p:pic>
+      <p:pic>
+        <p:nvPicPr>
+          <p:cNvPr id="8" name="图片 7"/>
+          <p:cNvPicPr>
+            <a:picLocks noChangeAspect="1"/>
+          </p:cNvPicPr>
+          <p:nvPr>
+            <p:custDataLst>
+              <p:tags r:id="rId9"/>
+            </p:custDataLst>
+          </p:nvPr>
+        </p:nvPicPr>
+        <p:blipFill>
+          <a:blip r:embed="rId10"/>
+          <a:stretch>
+            <a:fillRect/>
+          </a:stretch>
+        </p:blipFill>
+        <p:spPr>
+          <a:xfrm>
+            <a:off x="6062980" y="4991100"/>
+            <a:ext cx="5054600" cy="1866900"/>
+          </a:xfrm>
+          <a:prstGeom prst="rect">
+            <a:avLst/>
+          </a:prstGeom>
+        </p:spPr>
+      </p:pic>
+    </p:spTree>
+  </p:cSld>
+  <p:clrMapOvr>
+    <a:masterClrMapping/>
+  </p:clrMapOvr>
+</p:sld>
+</file>
+
+<file path=ppt/slides/slide8.xml><?xml version="1.0" encoding="utf-8"?>
+<p:sld xmlns:a="http://schemas.openxmlformats.org/drawingml/2006/main" xmlns:r="http://schemas.openxmlformats.org/officeDocument/2006/relationships" xmlns:p="http://schemas.openxmlformats.org/presentationml/2006/main">
+  <p:cSld>
+    <p:spTree>
+      <p:nvGrpSpPr>
+        <p:cNvPr id="1" name=""/>
+        <p:cNvGrpSpPr/>
+        <p:nvPr/>
+      </p:nvGrpSpPr>
+      <p:grpSpPr/>
+      <p:sp>
+        <p:nvSpPr>
+          <p:cNvPr id="2" name="标题 1"/>
+          <p:cNvSpPr>
+            <a:spLocks noGrp="1"/>
+          </p:cNvSpPr>
+          <p:nvPr>
+            <p:ph type="ctrTitle"/>
+          </p:nvPr>
+        </p:nvSpPr>
+        <p:spPr/>
+        <p:txBody>
+          <a:bodyPr/>
+          <a:p>
+            <a:r>
+              <a:rPr lang="zh-CN" altLang="en-US"/>
+              <a:t>Textual Inversions</a:t>
+            </a:r>
+            <a:endParaRPr lang="zh-CN" altLang="en-US"/>
+          </a:p>
+        </p:txBody>
+      </p:sp>
+      <p:sp>
+        <p:nvSpPr>
+          <p:cNvPr id="3" name="副标题 2"/>
+          <p:cNvSpPr>
+            <a:spLocks noGrp="1"/>
+          </p:cNvSpPr>
+          <p:nvPr>
+            <p:ph type="subTitle" idx="1"/>
+          </p:nvPr>
+        </p:nvSpPr>
+        <p:spPr/>
+        <p:txBody>
+          <a:bodyPr/>
+          <a:p>
+            <a:endParaRPr lang="zh-CN" altLang="en-US"/>
+          </a:p>
+        </p:txBody>
+      </p:sp>
+    </p:spTree>
+  </p:cSld>
+  <p:clrMapOvr>
+    <a:masterClrMapping/>
+  </p:clrMapOvr>
+</p:sld>
+</file>
+
+<file path=ppt/slides/slide9.xml><?xml version="1.0" encoding="utf-8"?>
+<p:sld xmlns:a="http://schemas.openxmlformats.org/drawingml/2006/main" xmlns:r="http://schemas.openxmlformats.org/officeDocument/2006/relationships" xmlns:p="http://schemas.openxmlformats.org/presentationml/2006/main">
+  <p:cSld>
+    <p:spTree>
+      <p:nvGrpSpPr>
+        <p:cNvPr id="1" name=""/>
+        <p:cNvGrpSpPr/>
+        <p:nvPr/>
+      </p:nvGrpSpPr>
+      <p:grpSpPr/>
+      <p:pic>
+        <p:nvPicPr>
+          <p:cNvPr id="4" name="图片 3"/>
+          <p:cNvPicPr>
+            <a:picLocks noChangeAspect="1"/>
+          </p:cNvPicPr>
+          <p:nvPr>
+            <p:custDataLst>
+              <p:tags r:id="rId1"/>
+            </p:custDataLst>
+          </p:nvPr>
+        </p:nvPicPr>
+        <p:blipFill>
+          <a:blip r:embed="rId2"/>
+          <a:stretch>
+            <a:fillRect/>
+          </a:stretch>
+        </p:blipFill>
+        <p:spPr>
+          <a:xfrm>
+            <a:off x="0" y="0"/>
+            <a:ext cx="9499600" cy="5270500"/>
+          </a:xfrm>
+          <a:prstGeom prst="rect">
+            <a:avLst/>
+          </a:prstGeom>
+        </p:spPr>
+      </p:pic>
+      <p:pic>
+        <p:nvPicPr>
+          <p:cNvPr id="5" name="图片 4"/>
+          <p:cNvPicPr>
+            <a:picLocks noChangeAspect="1"/>
+          </p:cNvPicPr>
+          <p:nvPr>
+            <p:custDataLst>
+              <p:tags r:id="rId3"/>
+            </p:custDataLst>
+          </p:nvPr>
+        </p:nvPicPr>
+        <p:blipFill>
+          <a:blip r:embed="rId4"/>
+          <a:stretch>
+            <a:fillRect/>
+          </a:stretch>
+        </p:blipFill>
+        <p:spPr>
+          <a:xfrm>
+            <a:off x="259715" y="5867400"/>
+            <a:ext cx="5473700" cy="546100"/>
+          </a:xfrm>
+          <a:prstGeom prst="rect">
+            <a:avLst/>
+          </a:prstGeom>
+        </p:spPr>
+      </p:pic>
+      <p:sp>
+        <p:nvSpPr>
+          <p:cNvPr id="6" name="文本框 5"/>
+          <p:cNvSpPr txBox="1"/>
+          <p:nvPr>
+            <p:custDataLst>
+              <p:tags r:id="rId5"/>
+            </p:custDataLst>
+          </p:nvPr>
+        </p:nvSpPr>
+        <p:spPr>
+          <a:xfrm>
+            <a:off x="6120130" y="5986145"/>
+            <a:ext cx="4130040" cy="427355"/>
+          </a:xfrm>
+          <a:prstGeom prst="rect">
+            <a:avLst/>
+          </a:prstGeom>
+          <a:noFill/>
+        </p:spPr>
+        <p:txBody>
+          <a:bodyPr wrap="square" rtlCol="0">
+            <a:noAutofit/>
+          </a:bodyPr>
+          <a:p>
+            <a:pPr algn="l"/>
+            <a:r>
+              <a:rPr sz="1200" b="1">
+                <a:latin typeface="微软雅黑" charset="0"/>
+                <a:ea typeface="微软雅黑" charset="0"/>
+                <a:cs typeface="微软雅黑" charset="0"/>
+              </a:rPr>
+              <a:t>找到一个最优的嵌入向量 v</a:t>
+            </a:r>
+            <a:r>
+              <a:rPr lang="en-US" sz="1200" b="1">
+                <a:latin typeface="微软雅黑" charset="0"/>
+                <a:ea typeface="微软雅黑" charset="0"/>
+                <a:cs typeface="微软雅黑" charset="0"/>
+              </a:rPr>
+              <a:t>*</a:t>
+            </a:r>
+            <a:r>
+              <a:rPr sz="1200" b="1">
+                <a:latin typeface="微软雅黑" charset="0"/>
+                <a:ea typeface="微软雅黑" charset="0"/>
+                <a:cs typeface="微软雅黑" charset="0"/>
+              </a:rPr>
+              <a:t>，使得通过它生成图像时，模型越能“还原”原始图像。</a:t>
+            </a:r>
+            <a:endParaRPr sz="1200" b="1">
+              <a:latin typeface="微软雅黑" charset="0"/>
+              <a:ea typeface="微软雅黑" charset="0"/>
+              <a:cs typeface="微软雅黑" charset="0"/>
+            </a:endParaRPr>
+          </a:p>
+        </p:txBody>
+      </p:sp>
+      <p:sp>
+        <p:nvSpPr>
+          <p:cNvPr id="16" name="矩形: 圆角 36"/>
+          <p:cNvSpPr/>
+          <p:nvPr>
+            <p:custDataLst>
+              <p:tags r:id="rId6"/>
+            </p:custDataLst>
+          </p:nvPr>
+        </p:nvSpPr>
+        <p:spPr>
+          <a:xfrm rot="10800000" flipV="1">
+            <a:off x="3038475" y="3073400"/>
+            <a:ext cx="2087880" cy="2321560"/>
+          </a:xfrm>
+          <a:prstGeom prst="roundRect">
+            <a:avLst>
+              <a:gd name="adj" fmla="val 10039"/>
+            </a:avLst>
+          </a:prstGeom>
+          <a:noFill/>
+          <a:ln w="38100">
+            <a:solidFill>
+              <a:schemeClr val="tx1"/>
+            </a:solidFill>
+            <a:prstDash val="lgDash"/>
+          </a:ln>
+        </p:spPr>
+        <p:style>
+          <a:lnRef idx="2">
+            <a:schemeClr val="accent1">
+              <a:shade val="15000"/>
+            </a:schemeClr>
+          </a:lnRef>
+          <a:fillRef idx="1">
+            <a:schemeClr val="accent1"/>
+          </a:fillRef>
+          <a:effectRef idx="0">
+            <a:schemeClr val="accent1"/>
+          </a:effectRef>
+          <a:fontRef idx="minor">
+            <a:schemeClr val="lt1"/>
+          </a:fontRef>
+        </p:style>
+        <p:txBody>
+          <a:bodyPr rtlCol="0" anchor="ctr"/>
+          <a:p>
+            <a:pPr algn="ctr"/>
+            <a:endParaRPr lang="zh-CN" altLang="en-US"/>
+          </a:p>
+        </p:txBody>
+      </p:sp>
+      <p:sp>
+        <p:nvSpPr>
+          <p:cNvPr id="8" name="文本框 7"/>
+          <p:cNvSpPr txBox="1"/>
+          <p:nvPr>
+            <p:custDataLst>
+              <p:tags r:id="rId7"/>
+            </p:custDataLst>
+          </p:nvPr>
+        </p:nvSpPr>
+        <p:spPr>
+          <a:xfrm>
+            <a:off x="3038475" y="4583430"/>
+            <a:ext cx="2087880" cy="427355"/>
+          </a:xfrm>
+          <a:prstGeom prst="rect">
+            <a:avLst/>
+          </a:prstGeom>
+          <a:noFill/>
+        </p:spPr>
+        <p:txBody>
+          <a:bodyPr wrap="square" rtlCol="0">
+            <a:noAutofit/>
+          </a:bodyPr>
+          <a:p>
+            <a:pPr algn="l"/>
+            <a:r>
+              <a:rPr lang="zh-CN" sz="1200" b="1">
+                <a:latin typeface="微软雅黑" charset="0"/>
+                <a:ea typeface="微软雅黑" charset="0"/>
+                <a:cs typeface="微软雅黑" charset="0"/>
+              </a:rPr>
+              <a:t>模型要做的是通过学习不断地调整</a:t>
+            </a:r>
+            <a:r>
+              <a:rPr lang="en-US" altLang="zh-CN" sz="1200" b="1">
+                <a:latin typeface="微软雅黑" charset="0"/>
+                <a:ea typeface="微软雅黑" charset="0"/>
+                <a:cs typeface="微软雅黑" charset="0"/>
+              </a:rPr>
+              <a:t>v*</a:t>
+            </a:r>
+            <a:r>
+              <a:rPr lang="zh-CN" altLang="en-US" sz="1200" b="1">
+                <a:latin typeface="微软雅黑" charset="0"/>
+                <a:ea typeface="微软雅黑" charset="0"/>
+                <a:cs typeface="微软雅黑" charset="0"/>
+              </a:rPr>
+              <a:t>，从而让</a:t>
+            </a:r>
+            <a:r>
+              <a:rPr lang="en-US" altLang="zh-CN" sz="1200" b="1">
+                <a:latin typeface="微软雅黑" charset="0"/>
+                <a:ea typeface="微软雅黑" charset="0"/>
+                <a:cs typeface="微软雅黑" charset="0"/>
+              </a:rPr>
+              <a:t>T2I</a:t>
+            </a:r>
+            <a:r>
+              <a:rPr lang="zh-CN" altLang="en-US" sz="1200" b="1">
+                <a:latin typeface="微软雅黑" charset="0"/>
+                <a:ea typeface="微软雅黑" charset="0"/>
+                <a:cs typeface="微软雅黑" charset="0"/>
+              </a:rPr>
+              <a:t>模型生成的图像和给定的图像尽可能</a:t>
+            </a:r>
+            <a:r>
+              <a:rPr lang="zh-CN" altLang="en-US" sz="1200" b="1">
+                <a:latin typeface="微软雅黑" charset="0"/>
+                <a:ea typeface="微软雅黑" charset="0"/>
+                <a:cs typeface="微软雅黑" charset="0"/>
+              </a:rPr>
+              <a:t>相似</a:t>
+            </a:r>
+            <a:endParaRPr lang="zh-CN" altLang="en-US" sz="1200" b="1">
+              <a:latin typeface="微软雅黑" charset="0"/>
+              <a:ea typeface="微软雅黑" charset="0"/>
+              <a:cs typeface="微软雅黑" charset="0"/>
+            </a:endParaRPr>
+          </a:p>
+        </p:txBody>
+      </p:sp>
+    </p:spTree>
+  </p:cSld>
+  <p:clrMapOvr>
+    <a:masterClrMapping/>
+  </p:clrMapOvr>
+</p:sld>
+</file>
+
 <file path=ppt/tags/tag1.xml><?xml version="1.0" encoding="utf-8"?>
 <p:tagLst xmlns:p="http://schemas.openxmlformats.org/presentationml/2006/main">
   <p:tag name="KSO_WM_BEAUTIFY_FLAG" val=""/>
@@ -5863,13 +6864,115 @@
 </p:tagLst>
 </file>
 
+<file path=ppt/tags/tag37.xml><?xml version="1.0" encoding="utf-8"?>
+<p:tagLst xmlns:p="http://schemas.openxmlformats.org/presentationml/2006/main">
+  <p:tag name="KSO_WM_BEAUTIFY_FLAG" val=""/>
+</p:tagLst>
+</file>
+
+<file path=ppt/tags/tag38.xml><?xml version="1.0" encoding="utf-8"?>
+<p:tagLst xmlns:p="http://schemas.openxmlformats.org/presentationml/2006/main">
+  <p:tag name="KSO_WM_BEAUTIFY_FLAG" val=""/>
+</p:tagLst>
+</file>
+
+<file path=ppt/tags/tag39.xml><?xml version="1.0" encoding="utf-8"?>
+<p:tagLst xmlns:p="http://schemas.openxmlformats.org/presentationml/2006/main">
+  <p:tag name="KSO_WM_BEAUTIFY_FLAG" val=""/>
+</p:tagLst>
+</file>
+
 <file path=ppt/tags/tag4.xml><?xml version="1.0" encoding="utf-8"?>
 <p:tagLst xmlns:p="http://schemas.openxmlformats.org/presentationml/2006/main">
   <p:tag name="KSO_WM_BEAUTIFY_FLAG" val=""/>
 </p:tagLst>
 </file>
 
+<file path=ppt/tags/tag40.xml><?xml version="1.0" encoding="utf-8"?>
+<p:tagLst xmlns:p="http://schemas.openxmlformats.org/presentationml/2006/main">
+  <p:tag name="KSO_WM_BEAUTIFY_FLAG" val=""/>
+</p:tagLst>
+</file>
+
+<file path=ppt/tags/tag41.xml><?xml version="1.0" encoding="utf-8"?>
+<p:tagLst xmlns:p="http://schemas.openxmlformats.org/presentationml/2006/main">
+  <p:tag name="KSO_WM_BEAUTIFY_FLAG" val=""/>
+</p:tagLst>
+</file>
+
+<file path=ppt/tags/tag42.xml><?xml version="1.0" encoding="utf-8"?>
+<p:tagLst xmlns:p="http://schemas.openxmlformats.org/presentationml/2006/main">
+  <p:tag name="KSO_WM_BEAUTIFY_FLAG" val=""/>
+</p:tagLst>
+</file>
+
+<file path=ppt/tags/tag43.xml><?xml version="1.0" encoding="utf-8"?>
+<p:tagLst xmlns:p="http://schemas.openxmlformats.org/presentationml/2006/main">
+  <p:tag name="KSO_WM_BEAUTIFY_FLAG" val=""/>
+</p:tagLst>
+</file>
+
+<file path=ppt/tags/tag44.xml><?xml version="1.0" encoding="utf-8"?>
+<p:tagLst xmlns:p="http://schemas.openxmlformats.org/presentationml/2006/main">
+  <p:tag name="KSO_WM_BEAUTIFY_FLAG" val=""/>
+</p:tagLst>
+</file>
+
+<file path=ppt/tags/tag45.xml><?xml version="1.0" encoding="utf-8"?>
+<p:tagLst xmlns:p="http://schemas.openxmlformats.org/presentationml/2006/main">
+  <p:tag name="KSO_WM_BEAUTIFY_FLAG" val=""/>
+</p:tagLst>
+</file>
+
+<file path=ppt/tags/tag46.xml><?xml version="1.0" encoding="utf-8"?>
+<p:tagLst xmlns:p="http://schemas.openxmlformats.org/presentationml/2006/main">
+  <p:tag name="KSO_WM_BEAUTIFY_FLAG" val=""/>
+</p:tagLst>
+</file>
+
+<file path=ppt/tags/tag47.xml><?xml version="1.0" encoding="utf-8"?>
+<p:tagLst xmlns:p="http://schemas.openxmlformats.org/presentationml/2006/main">
+  <p:tag name="KSO_WM_BEAUTIFY_FLAG" val=""/>
+</p:tagLst>
+</file>
+
+<file path=ppt/tags/tag48.xml><?xml version="1.0" encoding="utf-8"?>
+<p:tagLst xmlns:p="http://schemas.openxmlformats.org/presentationml/2006/main">
+  <p:tag name="KSO_WM_BEAUTIFY_FLAG" val=""/>
+</p:tagLst>
+</file>
+
+<file path=ppt/tags/tag49.xml><?xml version="1.0" encoding="utf-8"?>
+<p:tagLst xmlns:p="http://schemas.openxmlformats.org/presentationml/2006/main">
+  <p:tag name="KSO_WM_BEAUTIFY_FLAG" val=""/>
+</p:tagLst>
+</file>
+
 <file path=ppt/tags/tag5.xml><?xml version="1.0" encoding="utf-8"?>
+<p:tagLst xmlns:p="http://schemas.openxmlformats.org/presentationml/2006/main">
+  <p:tag name="KSO_WM_BEAUTIFY_FLAG" val=""/>
+</p:tagLst>
+</file>
+
+<file path=ppt/tags/tag50.xml><?xml version="1.0" encoding="utf-8"?>
+<p:tagLst xmlns:p="http://schemas.openxmlformats.org/presentationml/2006/main">
+  <p:tag name="KSO_WM_BEAUTIFY_FLAG" val=""/>
+</p:tagLst>
+</file>
+
+<file path=ppt/tags/tag51.xml><?xml version="1.0" encoding="utf-8"?>
+<p:tagLst xmlns:p="http://schemas.openxmlformats.org/presentationml/2006/main">
+  <p:tag name="KSO_WM_BEAUTIFY_FLAG" val=""/>
+</p:tagLst>
+</file>
+
+<file path=ppt/tags/tag52.xml><?xml version="1.0" encoding="utf-8"?>
+<p:tagLst xmlns:p="http://schemas.openxmlformats.org/presentationml/2006/main">
+  <p:tag name="KSO_WM_BEAUTIFY_FLAG" val=""/>
+</p:tagLst>
+</file>
+
+<file path=ppt/tags/tag53.xml><?xml version="1.0" encoding="utf-8"?>
 <p:tagLst xmlns:p="http://schemas.openxmlformats.org/presentationml/2006/main">
   <p:tag name="KSO_WM_BEAUTIFY_FLAG" val=""/>
 </p:tagLst>

</xml_diff>